<commit_message>
Highlight area-scoped requirements in the product overview pitch
Adds a new feature section/slide covering the area-scoped requirements
work: define skill requirements per area of the floor (Counter,
Fitting Room, Concierge, etc.) alongside shift-wide ones, with the
area carried through generation, manual edits, exports and each
employee's own schedule. No real screenshot exists for this yet, so
it's presented as a labeled illustrative diagram rather than a
screenshot, in both the HTML and the pptx (matching styling).

Also updates the executive summary's "what changed recently" card and
adds a bullet to the manual-edit feature describing area reassignment
during roster editing, in both product-overview.html and
build-pptx.py, and regenerates product-overview.pptx by running the
script. dist/introduction/ is synced to match public/introduction/
without a full app rebuild, since only this static content changed.
</commit_message>
<xml_diff>
--- a/frontend/dist/introduction/product-overview.pptx
+++ b/frontend/dist/introduction/product-overview.pptx
@@ -22,6 +22,8 @@
     <p:sldId id="270" r:id="rId21"/>
     <p:sldId id="271" r:id="rId22"/>
     <p:sldId id="272" r:id="rId23"/>
+    <p:sldId id="273" r:id="rId24"/>
+    <p:sldId id="274" r:id="rId25"/>
   </p:sldIdLst>
   <p:sldSz cx="12191695" cy="6858000" type="screen4x3"/>
   <p:notesSz cx="6858000" cy="9144000"/>
@@ -3545,36 +3547,41 @@
           </a:p>
         </p:txBody>
       </p:sp>
-      <p:pic>
-        <p:nvPicPr>
-          <p:cNvPr id="3" name="Picture 2" descr="admin-rules.png"/>
-          <p:cNvPicPr>
-            <a:picLocks noChangeAspect="1"/>
-          </p:cNvPicPr>
-          <p:nvPr/>
-        </p:nvPicPr>
-        <p:blipFill>
-          <a:blip r:embed="rId2"/>
-          <a:stretch>
-            <a:fillRect/>
-          </a:stretch>
-        </p:blipFill>
-        <p:spPr>
-          <a:xfrm>
-            <a:off x="640080" y="822960"/>
-            <a:ext cx="5074920" cy="5314569"/>
-          </a:xfrm>
-          <a:prstGeom prst="rect">
-            <a:avLst/>
-          </a:prstGeom>
-          <a:ln w="9525">
-            <a:solidFill>
-              <a:srgbClr val="E3E1DA"/>
-            </a:solidFill>
-          </a:ln>
-          <a:effectLst/>
-        </p:spPr>
-      </p:pic>
+      <p:sp>
+        <p:nvSpPr>
+          <p:cNvPr id="3" name="TextBox 2"/>
+          <p:cNvSpPr txBox="1"/>
+          <p:nvPr/>
+        </p:nvSpPr>
+        <p:spPr>
+          <a:xfrm>
+            <a:off x="640080" y="685800"/>
+            <a:ext cx="5425135" cy="320040"/>
+          </a:xfrm>
+          <a:prstGeom prst="rect">
+            <a:avLst/>
+          </a:prstGeom>
+          <a:noFill/>
+        </p:spPr>
+        <p:txBody>
+          <a:bodyPr wrap="square" anchor="t">
+            <a:noAutofit/>
+          </a:bodyPr>
+          <a:lstStyle/>
+          <a:p>
+            <a:pPr algn="l"/>
+            <a:r>
+              <a:rPr sz="1050" b="1" i="0">
+                <a:solidFill>
+                  <a:srgbClr val="C9A84C"/>
+                </a:solidFill>
+                <a:latin typeface="Arial"/>
+              </a:rPr>
+              <a:t>ADMIN · SHIFTS &amp; ROSTERS</a:t>
+            </a:r>
+          </a:p>
+        </p:txBody>
+      </p:sp>
       <p:sp>
         <p:nvSpPr>
           <p:cNvPr id="4" name="TextBox 3"/>
@@ -3583,77 +3590,7 @@
         </p:nvSpPr>
         <p:spPr>
           <a:xfrm>
-            <a:off x="640080" y="6228969"/>
-            <a:ext cx="5074920" cy="457200"/>
-          </a:xfrm>
-          <a:prstGeom prst="rect">
-            <a:avLst/>
-          </a:prstGeom>
-          <a:noFill/>
-        </p:spPr>
-        <p:txBody>
-          <a:bodyPr wrap="square" anchor="t">
-            <a:noAutofit/>
-          </a:bodyPr>
-          <a:lstStyle/>
-          <a:p>
-            <a:pPr algn="ctr"/>
-            <a:r>
-              <a:rPr sz="1000" b="0" i="1">
-                <a:solidFill>
-                  <a:srgbClr val="6B6B6B"/>
-                </a:solidFill>
-                <a:latin typeface="Arial"/>
-              </a:rPr>
-              <a:t>Eight constraint rules, engine thresholds and scoring weights — all per boutique</a:t>
-            </a:r>
-          </a:p>
-        </p:txBody>
-      </p:sp>
-      <p:sp>
-        <p:nvSpPr>
-          <p:cNvPr id="5" name="TextBox 4"/>
-          <p:cNvSpPr txBox="1"/>
-          <p:nvPr/>
-        </p:nvSpPr>
-        <p:spPr>
-          <a:xfrm>
-            <a:off x="6126480" y="685800"/>
-            <a:ext cx="5425135" cy="320040"/>
-          </a:xfrm>
-          <a:prstGeom prst="rect">
-            <a:avLst/>
-          </a:prstGeom>
-          <a:noFill/>
-        </p:spPr>
-        <p:txBody>
-          <a:bodyPr wrap="square" anchor="t">
-            <a:noAutofit/>
-          </a:bodyPr>
-          <a:lstStyle/>
-          <a:p>
-            <a:pPr algn="l"/>
-            <a:r>
-              <a:rPr sz="1050" b="1" i="0">
-                <a:solidFill>
-                  <a:srgbClr val="C9A84C"/>
-                </a:solidFill>
-                <a:latin typeface="Arial"/>
-              </a:rPr>
-              <a:t>ADMIN · RULES</a:t>
-            </a:r>
-          </a:p>
-        </p:txBody>
-      </p:sp>
-      <p:sp>
-        <p:nvSpPr>
-          <p:cNvPr id="6" name="TextBox 5"/>
-          <p:cNvSpPr txBox="1"/>
-          <p:nvPr/>
-        </p:nvSpPr>
-        <p:spPr>
-          <a:xfrm>
-            <a:off x="6126480" y="1024128"/>
+            <a:off x="640080" y="1024128"/>
             <a:ext cx="5425135" cy="1234440"/>
           </a:xfrm>
           <a:prstGeom prst="rect">
@@ -3679,20 +3616,20 @@
                 </a:solidFill>
                 <a:latin typeface="Georgia"/>
               </a:rPr>
-              <a:t>Tune the engine without touching a line of code.</a:t>
-            </a:r>
-          </a:p>
-        </p:txBody>
-      </p:sp>
-      <p:sp>
-        <p:nvSpPr>
-          <p:cNvPr id="7" name="TextBox 6"/>
-          <p:cNvSpPr txBox="1"/>
-          <p:nvPr/>
-        </p:nvSpPr>
-        <p:spPr>
-          <a:xfrm>
-            <a:off x="6126480" y="2331720"/>
+              <a:t>Staffing minimums for a specific part of the floor, not just the shift as a whole.</a:t>
+            </a:r>
+          </a:p>
+        </p:txBody>
+      </p:sp>
+      <p:sp>
+        <p:nvSpPr>
+          <p:cNvPr id="5" name="TextBox 4"/>
+          <p:cNvSpPr txBox="1"/>
+          <p:nvPr/>
+        </p:nvSpPr>
+        <p:spPr>
+          <a:xfrm>
+            <a:off x="640080" y="2331720"/>
             <a:ext cx="5425135" cy="1600200"/>
           </a:xfrm>
           <a:prstGeom prst="rect">
@@ -3718,20 +3655,20 @@
                 </a:solidFill>
                 <a:latin typeface="Arial"/>
               </a:rPr>
-              <a:t>Eight constraint rules — hours, fatigue, compliance, coverage and availability — can each be switched between warning and hard-block, independently per boutique.</a:t>
-            </a:r>
-          </a:p>
-        </p:txBody>
-      </p:sp>
-      <p:sp>
-        <p:nvSpPr>
-          <p:cNvPr id="8" name="TextBox 7"/>
-          <p:cNvSpPr txBox="1"/>
-          <p:nvPr/>
-        </p:nvSpPr>
-        <p:spPr>
-          <a:xfrm>
-            <a:off x="6126480" y="4069080"/>
+              <a:t>Areas — Counter, Fitting Room, Concierge, Stockroom, or however a boutique lays out its floor — carry their own skill requirements alongside the shift-wide ones. The scheduling engine fills the tighter, area-specific need first, then rounds out the rest of the shift from whoever's left.</a:t>
+            </a:r>
+          </a:p>
+        </p:txBody>
+      </p:sp>
+      <p:sp>
+        <p:nvSpPr>
+          <p:cNvPr id="6" name="TextBox 5"/>
+          <p:cNvSpPr txBox="1"/>
+          <p:nvPr/>
+        </p:nvSpPr>
+        <p:spPr>
+          <a:xfrm>
+            <a:off x="640080" y="4069080"/>
             <a:ext cx="5425135" cy="2194560"/>
           </a:xfrm>
           <a:prstGeom prst="rect">
@@ -3769,7 +3706,7 @@
                 </a:solidFill>
                 <a:latin typeface="Arial"/>
               </a:rPr>
-              <a:t>Hard-block vs. warning severity, set per rule</a:t>
+              <a:t>Define any number of areas per boutique, activated or retired independently — no code change to add one</a:t>
             </a:r>
           </a:p>
           <a:p>
@@ -3797,7 +3734,7 @@
                 </a:solidFill>
                 <a:latin typeface="Arial"/>
               </a:rPr>
-              <a:t>Target headcount, max hours, rest hours and VIC boost all editable</a:t>
+              <a:t>A requirement can be area-specific or shift-wide, and both are supported side by side on the same shift</a:t>
             </a:r>
           </a:p>
           <a:p>
@@ -3825,7 +3762,676 @@
                 </a:solidFill>
                 <a:latin typeface="Arial"/>
               </a:rPr>
-              <a:t>Scoring weights validated to sum to 1.0 before saving</a:t>
+              <a:t>Every assignment carries its area end to end: roster editing, CSV/PDF export, and each employee's own schedule</a:t>
+            </a:r>
+          </a:p>
+        </p:txBody>
+      </p:sp>
+      <p:sp>
+        <p:nvSpPr>
+          <p:cNvPr id="7" name="Rounded Rectangle 6"/>
+          <p:cNvSpPr/>
+          <p:nvPr/>
+        </p:nvSpPr>
+        <p:spPr>
+          <a:xfrm>
+            <a:off x="6476695" y="1280160"/>
+            <a:ext cx="5074920" cy="3429000"/>
+          </a:xfrm>
+          <a:prstGeom prst="roundRect">
+            <a:avLst>
+              <a:gd name="adj" fmla="val 6000"/>
+            </a:avLst>
+          </a:prstGeom>
+          <a:solidFill>
+            <a:srgbClr val="FFFFFF"/>
+          </a:solidFill>
+          <a:ln w="9525">
+            <a:solidFill>
+              <a:srgbClr val="E3E1DA"/>
+            </a:solidFill>
+          </a:ln>
+        </p:spPr>
+        <p:style>
+          <a:lnRef idx="1">
+            <a:schemeClr val="accent1"/>
+          </a:lnRef>
+          <a:fillRef idx="3">
+            <a:schemeClr val="accent1"/>
+          </a:fillRef>
+          <a:effectRef idx="2">
+            <a:schemeClr val="accent1"/>
+          </a:effectRef>
+          <a:fontRef idx="minor">
+            <a:schemeClr val="lt1"/>
+          </a:fontRef>
+        </p:style>
+        <p:txBody>
+          <a:bodyPr rtlCol="0" anchor="ctr"/>
+          <a:lstStyle/>
+          <a:p>
+            <a:pPr algn="ctr"/>
+          </a:p>
+        </p:txBody>
+      </p:sp>
+      <p:sp>
+        <p:nvSpPr>
+          <p:cNvPr id="8" name="TextBox 7"/>
+          <p:cNvSpPr txBox="1"/>
+          <p:nvPr/>
+        </p:nvSpPr>
+        <p:spPr>
+          <a:xfrm>
+            <a:off x="6751015" y="1481328"/>
+            <a:ext cx="4526280" cy="365760"/>
+          </a:xfrm>
+          <a:prstGeom prst="rect">
+            <a:avLst/>
+          </a:prstGeom>
+          <a:noFill/>
+        </p:spPr>
+        <p:txBody>
+          <a:bodyPr wrap="square" anchor="t">
+            <a:noAutofit/>
+          </a:bodyPr>
+          <a:lstStyle/>
+          <a:p>
+            <a:pPr algn="l"/>
+            <a:r>
+              <a:rPr sz="1300" b="0" i="0">
+                <a:solidFill>
+                  <a:srgbClr val="1E2761"/>
+                </a:solidFill>
+                <a:latin typeface="Georgia"/>
+              </a:rPr>
+              <a:t>Shift: Opening — requirements by area</a:t>
+            </a:r>
+          </a:p>
+        </p:txBody>
+      </p:sp>
+      <p:sp>
+        <p:nvSpPr>
+          <p:cNvPr id="9" name="Rounded Rectangle 8"/>
+          <p:cNvSpPr/>
+          <p:nvPr/>
+        </p:nvSpPr>
+        <p:spPr>
+          <a:xfrm>
+            <a:off x="6705295" y="2057400"/>
+            <a:ext cx="4617720" cy="493776"/>
+          </a:xfrm>
+          <a:prstGeom prst="roundRect">
+            <a:avLst>
+              <a:gd name="adj" fmla="val 6000"/>
+            </a:avLst>
+          </a:prstGeom>
+          <a:solidFill>
+            <a:srgbClr val="F5F0E8"/>
+          </a:solidFill>
+          <a:ln>
+            <a:noFill/>
+          </a:ln>
+          <a:effectLst/>
+        </p:spPr>
+        <p:style>
+          <a:lnRef idx="1">
+            <a:schemeClr val="accent1"/>
+          </a:lnRef>
+          <a:fillRef idx="3">
+            <a:schemeClr val="accent1"/>
+          </a:fillRef>
+          <a:effectRef idx="2">
+            <a:schemeClr val="accent1"/>
+          </a:effectRef>
+          <a:fontRef idx="minor">
+            <a:schemeClr val="lt1"/>
+          </a:fontRef>
+        </p:style>
+        <p:txBody>
+          <a:bodyPr rtlCol="0" anchor="ctr"/>
+          <a:lstStyle/>
+          <a:p>
+            <a:pPr algn="ctr"/>
+          </a:p>
+        </p:txBody>
+      </p:sp>
+      <p:sp>
+        <p:nvSpPr>
+          <p:cNvPr id="10" name="TextBox 9"/>
+          <p:cNvSpPr txBox="1"/>
+          <p:nvPr/>
+        </p:nvSpPr>
+        <p:spPr>
+          <a:xfrm>
+            <a:off x="6888175" y="2057400"/>
+            <a:ext cx="1645920" cy="493776"/>
+          </a:xfrm>
+          <a:prstGeom prst="rect">
+            <a:avLst/>
+          </a:prstGeom>
+          <a:noFill/>
+        </p:spPr>
+        <p:txBody>
+          <a:bodyPr wrap="square" anchor="ctr">
+            <a:noAutofit/>
+          </a:bodyPr>
+          <a:lstStyle/>
+          <a:p>
+            <a:pPr algn="l"/>
+            <a:r>
+              <a:rPr sz="1150" b="1" i="0">
+                <a:solidFill>
+                  <a:srgbClr val="1E2761"/>
+                </a:solidFill>
+                <a:latin typeface="Arial"/>
+              </a:rPr>
+              <a:t>Counter</a:t>
+            </a:r>
+          </a:p>
+        </p:txBody>
+      </p:sp>
+      <p:sp>
+        <p:nvSpPr>
+          <p:cNvPr id="11" name="Rounded Rectangle 10"/>
+          <p:cNvSpPr/>
+          <p:nvPr/>
+        </p:nvSpPr>
+        <p:spPr>
+          <a:xfrm>
+            <a:off x="9859975" y="2121408"/>
+            <a:ext cx="1417320" cy="256032"/>
+          </a:xfrm>
+          <a:prstGeom prst="roundRect">
+            <a:avLst>
+              <a:gd name="adj" fmla="val 50000"/>
+            </a:avLst>
+          </a:prstGeom>
+          <a:solidFill>
+            <a:srgbClr val="FFFFFF"/>
+          </a:solidFill>
+          <a:ln>
+            <a:noFill/>
+          </a:ln>
+          <a:effectLst/>
+        </p:spPr>
+        <p:style>
+          <a:lnRef idx="1">
+            <a:schemeClr val="accent1"/>
+          </a:lnRef>
+          <a:fillRef idx="3">
+            <a:schemeClr val="accent1"/>
+          </a:fillRef>
+          <a:effectRef idx="2">
+            <a:schemeClr val="accent1"/>
+          </a:effectRef>
+          <a:fontRef idx="minor">
+            <a:schemeClr val="lt1"/>
+          </a:fontRef>
+        </p:style>
+        <p:txBody>
+          <a:bodyPr rtlCol="0" anchor="ctr" lIns="50800" rIns="50800" tIns="12700" bIns="12700">
+            <a:noAutofit/>
+          </a:bodyPr>
+          <a:lstStyle/>
+          <a:p>
+            <a:pPr algn="ctr"/>
+            <a:r>
+              <a:rPr sz="900" b="1">
+                <a:solidFill>
+                  <a:srgbClr val="1A1A1A"/>
+                </a:solidFill>
+                <a:latin typeface="Arial"/>
+              </a:rPr>
+              <a:t>CASHIER ×1</a:t>
+            </a:r>
+          </a:p>
+        </p:txBody>
+      </p:sp>
+      <p:sp>
+        <p:nvSpPr>
+          <p:cNvPr id="12" name="Rounded Rectangle 11"/>
+          <p:cNvSpPr/>
+          <p:nvPr/>
+        </p:nvSpPr>
+        <p:spPr>
+          <a:xfrm>
+            <a:off x="6705295" y="2679192"/>
+            <a:ext cx="4617720" cy="493776"/>
+          </a:xfrm>
+          <a:prstGeom prst="roundRect">
+            <a:avLst>
+              <a:gd name="adj" fmla="val 6000"/>
+            </a:avLst>
+          </a:prstGeom>
+          <a:solidFill>
+            <a:srgbClr val="F5F0E8"/>
+          </a:solidFill>
+          <a:ln>
+            <a:noFill/>
+          </a:ln>
+          <a:effectLst/>
+        </p:spPr>
+        <p:style>
+          <a:lnRef idx="1">
+            <a:schemeClr val="accent1"/>
+          </a:lnRef>
+          <a:fillRef idx="3">
+            <a:schemeClr val="accent1"/>
+          </a:fillRef>
+          <a:effectRef idx="2">
+            <a:schemeClr val="accent1"/>
+          </a:effectRef>
+          <a:fontRef idx="minor">
+            <a:schemeClr val="lt1"/>
+          </a:fontRef>
+        </p:style>
+        <p:txBody>
+          <a:bodyPr rtlCol="0" anchor="ctr"/>
+          <a:lstStyle/>
+          <a:p>
+            <a:pPr algn="ctr"/>
+          </a:p>
+        </p:txBody>
+      </p:sp>
+      <p:sp>
+        <p:nvSpPr>
+          <p:cNvPr id="13" name="TextBox 12"/>
+          <p:cNvSpPr txBox="1"/>
+          <p:nvPr/>
+        </p:nvSpPr>
+        <p:spPr>
+          <a:xfrm>
+            <a:off x="6888175" y="2679192"/>
+            <a:ext cx="1645920" cy="493776"/>
+          </a:xfrm>
+          <a:prstGeom prst="rect">
+            <a:avLst/>
+          </a:prstGeom>
+          <a:noFill/>
+        </p:spPr>
+        <p:txBody>
+          <a:bodyPr wrap="square" anchor="ctr">
+            <a:noAutofit/>
+          </a:bodyPr>
+          <a:lstStyle/>
+          <a:p>
+            <a:pPr algn="l"/>
+            <a:r>
+              <a:rPr sz="1150" b="1" i="0">
+                <a:solidFill>
+                  <a:srgbClr val="1E2761"/>
+                </a:solidFill>
+                <a:latin typeface="Arial"/>
+              </a:rPr>
+              <a:t>Fitting Room</a:t>
+            </a:r>
+          </a:p>
+        </p:txBody>
+      </p:sp>
+      <p:sp>
+        <p:nvSpPr>
+          <p:cNvPr id="14" name="Rounded Rectangle 13"/>
+          <p:cNvSpPr/>
+          <p:nvPr/>
+        </p:nvSpPr>
+        <p:spPr>
+          <a:xfrm>
+            <a:off x="9859975" y="2743200"/>
+            <a:ext cx="1417320" cy="256032"/>
+          </a:xfrm>
+          <a:prstGeom prst="roundRect">
+            <a:avLst>
+              <a:gd name="adj" fmla="val 50000"/>
+            </a:avLst>
+          </a:prstGeom>
+          <a:solidFill>
+            <a:srgbClr val="FFFFFF"/>
+          </a:solidFill>
+          <a:ln>
+            <a:noFill/>
+          </a:ln>
+          <a:effectLst/>
+        </p:spPr>
+        <p:style>
+          <a:lnRef idx="1">
+            <a:schemeClr val="accent1"/>
+          </a:lnRef>
+          <a:fillRef idx="3">
+            <a:schemeClr val="accent1"/>
+          </a:fillRef>
+          <a:effectRef idx="2">
+            <a:schemeClr val="accent1"/>
+          </a:effectRef>
+          <a:fontRef idx="minor">
+            <a:schemeClr val="lt1"/>
+          </a:fontRef>
+        </p:style>
+        <p:txBody>
+          <a:bodyPr rtlCol="0" anchor="ctr" lIns="50800" rIns="50800" tIns="12700" bIns="12700">
+            <a:noAutofit/>
+          </a:bodyPr>
+          <a:lstStyle/>
+          <a:p>
+            <a:pPr algn="ctr"/>
+            <a:r>
+              <a:rPr sz="900" b="1">
+                <a:solidFill>
+                  <a:srgbClr val="1A1A1A"/>
+                </a:solidFill>
+                <a:latin typeface="Arial"/>
+              </a:rPr>
+              <a:t>SR. STYLIST ×1</a:t>
+            </a:r>
+          </a:p>
+        </p:txBody>
+      </p:sp>
+      <p:sp>
+        <p:nvSpPr>
+          <p:cNvPr id="15" name="Rounded Rectangle 14"/>
+          <p:cNvSpPr/>
+          <p:nvPr/>
+        </p:nvSpPr>
+        <p:spPr>
+          <a:xfrm>
+            <a:off x="6705295" y="3300984"/>
+            <a:ext cx="4617720" cy="493776"/>
+          </a:xfrm>
+          <a:prstGeom prst="roundRect">
+            <a:avLst>
+              <a:gd name="adj" fmla="val 6000"/>
+            </a:avLst>
+          </a:prstGeom>
+          <a:solidFill>
+            <a:srgbClr val="F5F0E8"/>
+          </a:solidFill>
+          <a:ln>
+            <a:noFill/>
+          </a:ln>
+          <a:effectLst/>
+        </p:spPr>
+        <p:style>
+          <a:lnRef idx="1">
+            <a:schemeClr val="accent1"/>
+          </a:lnRef>
+          <a:fillRef idx="3">
+            <a:schemeClr val="accent1"/>
+          </a:fillRef>
+          <a:effectRef idx="2">
+            <a:schemeClr val="accent1"/>
+          </a:effectRef>
+          <a:fontRef idx="minor">
+            <a:schemeClr val="lt1"/>
+          </a:fontRef>
+        </p:style>
+        <p:txBody>
+          <a:bodyPr rtlCol="0" anchor="ctr"/>
+          <a:lstStyle/>
+          <a:p>
+            <a:pPr algn="ctr"/>
+          </a:p>
+        </p:txBody>
+      </p:sp>
+      <p:sp>
+        <p:nvSpPr>
+          <p:cNvPr id="16" name="TextBox 15"/>
+          <p:cNvSpPr txBox="1"/>
+          <p:nvPr/>
+        </p:nvSpPr>
+        <p:spPr>
+          <a:xfrm>
+            <a:off x="6888175" y="3300984"/>
+            <a:ext cx="1645920" cy="493776"/>
+          </a:xfrm>
+          <a:prstGeom prst="rect">
+            <a:avLst/>
+          </a:prstGeom>
+          <a:noFill/>
+        </p:spPr>
+        <p:txBody>
+          <a:bodyPr wrap="square" anchor="ctr">
+            <a:noAutofit/>
+          </a:bodyPr>
+          <a:lstStyle/>
+          <a:p>
+            <a:pPr algn="l"/>
+            <a:r>
+              <a:rPr sz="1150" b="1" i="0">
+                <a:solidFill>
+                  <a:srgbClr val="1E2761"/>
+                </a:solidFill>
+                <a:latin typeface="Arial"/>
+              </a:rPr>
+              <a:t>Concierge</a:t>
+            </a:r>
+          </a:p>
+        </p:txBody>
+      </p:sp>
+      <p:sp>
+        <p:nvSpPr>
+          <p:cNvPr id="17" name="Rounded Rectangle 16"/>
+          <p:cNvSpPr/>
+          <p:nvPr/>
+        </p:nvSpPr>
+        <p:spPr>
+          <a:xfrm>
+            <a:off x="9859975" y="3364992"/>
+            <a:ext cx="1417320" cy="256032"/>
+          </a:xfrm>
+          <a:prstGeom prst="roundRect">
+            <a:avLst>
+              <a:gd name="adj" fmla="val 50000"/>
+            </a:avLst>
+          </a:prstGeom>
+          <a:solidFill>
+            <a:srgbClr val="FFFFFF"/>
+          </a:solidFill>
+          <a:ln>
+            <a:noFill/>
+          </a:ln>
+          <a:effectLst/>
+        </p:spPr>
+        <p:style>
+          <a:lnRef idx="1">
+            <a:schemeClr val="accent1"/>
+          </a:lnRef>
+          <a:fillRef idx="3">
+            <a:schemeClr val="accent1"/>
+          </a:fillRef>
+          <a:effectRef idx="2">
+            <a:schemeClr val="accent1"/>
+          </a:effectRef>
+          <a:fontRef idx="minor">
+            <a:schemeClr val="lt1"/>
+          </a:fontRef>
+        </p:style>
+        <p:txBody>
+          <a:bodyPr rtlCol="0" anchor="ctr" lIns="50800" rIns="50800" tIns="12700" bIns="12700">
+            <a:noAutofit/>
+          </a:bodyPr>
+          <a:lstStyle/>
+          <a:p>
+            <a:pPr algn="ctr"/>
+            <a:r>
+              <a:rPr sz="900" b="1">
+                <a:solidFill>
+                  <a:srgbClr val="1A1A1A"/>
+                </a:solidFill>
+                <a:latin typeface="Arial"/>
+              </a:rPr>
+              <a:t>VIC ADVISOR ×1</a:t>
+            </a:r>
+          </a:p>
+        </p:txBody>
+      </p:sp>
+      <p:sp>
+        <p:nvSpPr>
+          <p:cNvPr id="18" name="Rounded Rectangle 17"/>
+          <p:cNvSpPr/>
+          <p:nvPr/>
+        </p:nvSpPr>
+        <p:spPr>
+          <a:xfrm>
+            <a:off x="6705295" y="3922776"/>
+            <a:ext cx="4617720" cy="493776"/>
+          </a:xfrm>
+          <a:prstGeom prst="roundRect">
+            <a:avLst>
+              <a:gd name="adj" fmla="val 6000"/>
+            </a:avLst>
+          </a:prstGeom>
+          <a:solidFill>
+            <a:srgbClr val="F5F0E8"/>
+          </a:solidFill>
+          <a:ln>
+            <a:noFill/>
+          </a:ln>
+          <a:effectLst/>
+        </p:spPr>
+        <p:style>
+          <a:lnRef idx="1">
+            <a:schemeClr val="accent1"/>
+          </a:lnRef>
+          <a:fillRef idx="3">
+            <a:schemeClr val="accent1"/>
+          </a:fillRef>
+          <a:effectRef idx="2">
+            <a:schemeClr val="accent1"/>
+          </a:effectRef>
+          <a:fontRef idx="minor">
+            <a:schemeClr val="lt1"/>
+          </a:fontRef>
+        </p:style>
+        <p:txBody>
+          <a:bodyPr rtlCol="0" anchor="ctr"/>
+          <a:lstStyle/>
+          <a:p>
+            <a:pPr algn="ctr"/>
+          </a:p>
+        </p:txBody>
+      </p:sp>
+      <p:sp>
+        <p:nvSpPr>
+          <p:cNvPr id="19" name="TextBox 18"/>
+          <p:cNvSpPr txBox="1"/>
+          <p:nvPr/>
+        </p:nvSpPr>
+        <p:spPr>
+          <a:xfrm>
+            <a:off x="6888175" y="3922776"/>
+            <a:ext cx="1645920" cy="493776"/>
+          </a:xfrm>
+          <a:prstGeom prst="rect">
+            <a:avLst/>
+          </a:prstGeom>
+          <a:noFill/>
+        </p:spPr>
+        <p:txBody>
+          <a:bodyPr wrap="square" anchor="ctr">
+            <a:noAutofit/>
+          </a:bodyPr>
+          <a:lstStyle/>
+          <a:p>
+            <a:pPr algn="l"/>
+            <a:r>
+              <a:rPr sz="1150" b="1" i="0">
+                <a:solidFill>
+                  <a:srgbClr val="1E2761"/>
+                </a:solidFill>
+                <a:latin typeface="Arial"/>
+              </a:rPr>
+              <a:t>Shift-wide</a:t>
+            </a:r>
+          </a:p>
+        </p:txBody>
+      </p:sp>
+      <p:sp>
+        <p:nvSpPr>
+          <p:cNvPr id="20" name="Rounded Rectangle 19"/>
+          <p:cNvSpPr/>
+          <p:nvPr/>
+        </p:nvSpPr>
+        <p:spPr>
+          <a:xfrm>
+            <a:off x="9859975" y="3986784"/>
+            <a:ext cx="1417320" cy="256032"/>
+          </a:xfrm>
+          <a:prstGeom prst="roundRect">
+            <a:avLst>
+              <a:gd name="adj" fmla="val 50000"/>
+            </a:avLst>
+          </a:prstGeom>
+          <a:solidFill>
+            <a:srgbClr val="FFFFFF"/>
+          </a:solidFill>
+          <a:ln>
+            <a:noFill/>
+          </a:ln>
+          <a:effectLst/>
+        </p:spPr>
+        <p:style>
+          <a:lnRef idx="1">
+            <a:schemeClr val="accent1"/>
+          </a:lnRef>
+          <a:fillRef idx="3">
+            <a:schemeClr val="accent1"/>
+          </a:fillRef>
+          <a:effectRef idx="2">
+            <a:schemeClr val="accent1"/>
+          </a:effectRef>
+          <a:fontRef idx="minor">
+            <a:schemeClr val="lt1"/>
+          </a:fontRef>
+        </p:style>
+        <p:txBody>
+          <a:bodyPr rtlCol="0" anchor="ctr" lIns="50800" rIns="50800" tIns="12700" bIns="12700">
+            <a:noAutofit/>
+          </a:bodyPr>
+          <a:lstStyle/>
+          <a:p>
+            <a:pPr algn="ctr"/>
+            <a:r>
+              <a:rPr sz="900" b="1">
+                <a:solidFill>
+                  <a:srgbClr val="1A1A1A"/>
+                </a:solidFill>
+                <a:latin typeface="Arial"/>
+              </a:rPr>
+              <a:t>FLOOR MANAGER ×1</a:t>
+            </a:r>
+          </a:p>
+        </p:txBody>
+      </p:sp>
+      <p:sp>
+        <p:nvSpPr>
+          <p:cNvPr id="21" name="TextBox 20"/>
+          <p:cNvSpPr txBox="1"/>
+          <p:nvPr/>
+        </p:nvSpPr>
+        <p:spPr>
+          <a:xfrm>
+            <a:off x="6476695" y="4818888"/>
+            <a:ext cx="5074920" cy="365760"/>
+          </a:xfrm>
+          <a:prstGeom prst="rect">
+            <a:avLst/>
+          </a:prstGeom>
+          <a:noFill/>
+        </p:spPr>
+        <p:txBody>
+          <a:bodyPr wrap="square" anchor="t">
+            <a:noAutofit/>
+          </a:bodyPr>
+          <a:lstStyle/>
+          <a:p>
+            <a:pPr algn="ctr"/>
+            <a:r>
+              <a:rPr sz="950" b="0" i="1">
+                <a:solidFill>
+                  <a:srgbClr val="6B6B6B"/>
+                </a:solidFill>
+                <a:latin typeface="Arial"/>
+              </a:rPr>
+              <a:t>Illustrative — a shift's skill requirements, broken out by area of the floor</a:t>
             </a:r>
           </a:p>
         </p:txBody>
@@ -3894,7 +4500,7 @@
       </p:sp>
       <p:pic>
         <p:nvPicPr>
-          <p:cNvPr id="3" name="Picture 2" descr="admin-leave.png"/>
+          <p:cNvPr id="3" name="Picture 2" descr="admin-rules.png"/>
           <p:cNvPicPr>
             <a:picLocks noChangeAspect="1"/>
           </p:cNvPicPr>
@@ -3908,8 +4514,8 @@
         </p:blipFill>
         <p:spPr>
           <a:xfrm>
-            <a:off x="6476695" y="822960"/>
-            <a:ext cx="5074920" cy="3594735"/>
+            <a:off x="640080" y="822960"/>
+            <a:ext cx="5074920" cy="5314569"/>
           </a:xfrm>
           <a:prstGeom prst="rect">
             <a:avLst/>
@@ -3930,7 +4536,7 @@
         </p:nvSpPr>
         <p:spPr>
           <a:xfrm>
-            <a:off x="6476695" y="4509135"/>
+            <a:off x="640080" y="6228969"/>
             <a:ext cx="5074920" cy="457200"/>
           </a:xfrm>
           <a:prstGeom prst="rect">
@@ -3952,7 +4558,7 @@
                 </a:solidFill>
                 <a:latin typeface="Arial"/>
               </a:rPr>
-              <a:t>Leave register — HR-synced, ad-hoc and manual records side by side</a:t>
+              <a:t>Eight constraint rules, engine thresholds and scoring weights — all per boutique</a:t>
             </a:r>
           </a:p>
         </p:txBody>
@@ -3965,7 +4571,7 @@
         </p:nvSpPr>
         <p:spPr>
           <a:xfrm>
-            <a:off x="640080" y="685800"/>
+            <a:off x="6126480" y="685800"/>
             <a:ext cx="5425135" cy="320040"/>
           </a:xfrm>
           <a:prstGeom prst="rect">
@@ -3987,7 +4593,7 @@
                 </a:solidFill>
                 <a:latin typeface="Arial"/>
               </a:rPr>
-              <a:t>ADMIN · LEAVE</a:t>
+              <a:t>ADMIN · RULES</a:t>
             </a:r>
           </a:p>
         </p:txBody>
@@ -4000,7 +4606,7 @@
         </p:nvSpPr>
         <p:spPr>
           <a:xfrm>
-            <a:off x="640080" y="1024128"/>
+            <a:off x="6126480" y="1024128"/>
             <a:ext cx="5425135" cy="1234440"/>
           </a:xfrm>
           <a:prstGeom prst="rect">
@@ -4026,7 +4632,7 @@
                 </a:solidFill>
                 <a:latin typeface="Georgia"/>
               </a:rPr>
-              <a:t>Leave feeds straight into who the engine considers available.</a:t>
+              <a:t>Tune the engine without touching a line of code.</a:t>
             </a:r>
           </a:p>
         </p:txBody>
@@ -4039,7 +4645,7 @@
         </p:nvSpPr>
         <p:spPr>
           <a:xfrm>
-            <a:off x="640080" y="2331720"/>
+            <a:off x="6126480" y="2331720"/>
             <a:ext cx="5425135" cy="1600200"/>
           </a:xfrm>
           <a:prstGeom prst="rect">
@@ -4065,7 +4671,7 @@
                 </a:solidFill>
                 <a:latin typeface="Arial"/>
               </a:rPr>
-              <a:t>Annual, sick, parental, unpaid and public-holiday leave are tracked per staff member, tagged by source, and automatically exclude that person from generation on those dates.</a:t>
+              <a:t>Eight constraint rules — hours, fatigue, compliance, coverage and availability — can each be switched between warning and hard-block, independently per boutique.</a:t>
             </a:r>
           </a:p>
         </p:txBody>
@@ -4078,7 +4684,7 @@
         </p:nvSpPr>
         <p:spPr>
           <a:xfrm>
-            <a:off x="640080" y="4069080"/>
+            <a:off x="6126480" y="4069080"/>
             <a:ext cx="5425135" cy="2194560"/>
           </a:xfrm>
           <a:prstGeom prst="rect">
@@ -4116,7 +4722,7 @@
                 </a:solidFill>
                 <a:latin typeface="Arial"/>
               </a:rPr>
-              <a:t>Bulk "public holiday" entry for every staff member in one action</a:t>
+              <a:t>Hard-block vs. warning severity, set per rule</a:t>
             </a:r>
           </a:p>
           <a:p>
@@ -4144,7 +4750,7 @@
                 </a:solidFill>
                 <a:latin typeface="Arial"/>
               </a:rPr>
-              <a:t>HR-synced records are protected from accidental deletion</a:t>
+              <a:t>Target headcount, max hours, rest hours and VIC boost all editable</a:t>
             </a:r>
           </a:p>
           <a:p>
@@ -4172,7 +4778,7 @@
                 </a:solidFill>
                 <a:latin typeface="Arial"/>
               </a:rPr>
-              <a:t>Filterable by staff, leave type, source and date range</a:t>
+              <a:t>Scoring weights validated to sum to 1.0 before saving</a:t>
             </a:r>
           </a:p>
         </p:txBody>
@@ -4239,9 +4845,74 @@
           </a:p>
         </p:txBody>
       </p:sp>
-      <p:sp>
-        <p:nvSpPr>
-          <p:cNvPr id="3" name="TextBox 2"/>
+      <p:pic>
+        <p:nvPicPr>
+          <p:cNvPr id="3" name="Picture 2" descr="admin-leave.png"/>
+          <p:cNvPicPr>
+            <a:picLocks noChangeAspect="1"/>
+          </p:cNvPicPr>
+          <p:nvPr/>
+        </p:nvPicPr>
+        <p:blipFill>
+          <a:blip r:embed="rId2"/>
+          <a:stretch>
+            <a:fillRect/>
+          </a:stretch>
+        </p:blipFill>
+        <p:spPr>
+          <a:xfrm>
+            <a:off x="6476695" y="822960"/>
+            <a:ext cx="5074920" cy="3594735"/>
+          </a:xfrm>
+          <a:prstGeom prst="rect">
+            <a:avLst/>
+          </a:prstGeom>
+          <a:ln w="9525">
+            <a:solidFill>
+              <a:srgbClr val="E3E1DA"/>
+            </a:solidFill>
+          </a:ln>
+          <a:effectLst/>
+        </p:spPr>
+      </p:pic>
+      <p:sp>
+        <p:nvSpPr>
+          <p:cNvPr id="4" name="TextBox 3"/>
+          <p:cNvSpPr txBox="1"/>
+          <p:nvPr/>
+        </p:nvSpPr>
+        <p:spPr>
+          <a:xfrm>
+            <a:off x="6476695" y="4509135"/>
+            <a:ext cx="5074920" cy="457200"/>
+          </a:xfrm>
+          <a:prstGeom prst="rect">
+            <a:avLst/>
+          </a:prstGeom>
+          <a:noFill/>
+        </p:spPr>
+        <p:txBody>
+          <a:bodyPr wrap="square" anchor="t">
+            <a:noAutofit/>
+          </a:bodyPr>
+          <a:lstStyle/>
+          <a:p>
+            <a:pPr algn="ctr"/>
+            <a:r>
+              <a:rPr sz="1000" b="0" i="1">
+                <a:solidFill>
+                  <a:srgbClr val="6B6B6B"/>
+                </a:solidFill>
+                <a:latin typeface="Arial"/>
+              </a:rPr>
+              <a:t>Leave register — HR-synced, ad-hoc and manual records side by side</a:t>
+            </a:r>
+          </a:p>
+        </p:txBody>
+      </p:sp>
+      <p:sp>
+        <p:nvSpPr>
+          <p:cNvPr id="5" name="TextBox 4"/>
           <p:cNvSpPr txBox="1"/>
           <p:nvPr/>
         </p:nvSpPr>
@@ -4269,14 +4940,14 @@
                 </a:solidFill>
                 <a:latin typeface="Arial"/>
               </a:rPr>
-              <a:t>APPROVER · INBOX &amp; HISTORY</a:t>
-            </a:r>
-          </a:p>
-        </p:txBody>
-      </p:sp>
-      <p:sp>
-        <p:nvSpPr>
-          <p:cNvPr id="4" name="TextBox 3"/>
+              <a:t>ADMIN · LEAVE</a:t>
+            </a:r>
+          </a:p>
+        </p:txBody>
+      </p:sp>
+      <p:sp>
+        <p:nvSpPr>
+          <p:cNvPr id="6" name="TextBox 5"/>
           <p:cNvSpPr txBox="1"/>
           <p:nvPr/>
         </p:nvSpPr>
@@ -4308,21 +4979,21 @@
                 </a:solidFill>
                 <a:latin typeface="Georgia"/>
               </a:rPr>
-              <a:t>A second pair of eyes, kept structurally separate from the drafter.</a:t>
-            </a:r>
-          </a:p>
-        </p:txBody>
-      </p:sp>
-      <p:sp>
-        <p:nvSpPr>
-          <p:cNvPr id="5" name="TextBox 4"/>
+              <a:t>Leave feeds straight into who the engine considers available.</a:t>
+            </a:r>
+          </a:p>
+        </p:txBody>
+      </p:sp>
+      <p:sp>
+        <p:nvSpPr>
+          <p:cNvPr id="7" name="TextBox 6"/>
           <p:cNvSpPr txBox="1"/>
           <p:nvPr/>
         </p:nvSpPr>
         <p:spPr>
           <a:xfrm>
             <a:off x="640080" y="2331720"/>
-            <a:ext cx="5425135" cy="1737360"/>
+            <a:ext cx="5425135" cy="1600200"/>
           </a:xfrm>
           <a:prstGeom prst="rect">
             <a:avLst/>
@@ -4347,21 +5018,21 @@
                 </a:solidFill>
                 <a:latin typeface="Arial"/>
               </a:rPr>
-              <a:t>Approvers get a dedicated inbox of submitted rosters — score, overrides and full shift detail — with approve, reject (with a note back to the admin) and publish.</a:t>
-            </a:r>
-          </a:p>
-        </p:txBody>
-      </p:sp>
-      <p:sp>
-        <p:nvSpPr>
-          <p:cNvPr id="6" name="TextBox 5"/>
-          <p:cNvSpPr txBox="1"/>
-          <p:nvPr/>
-        </p:nvSpPr>
-        <p:spPr>
-          <a:xfrm>
-            <a:off x="640080" y="4160520"/>
-            <a:ext cx="5425135" cy="2103120"/>
+              <a:t>Annual, sick, parental, unpaid and public-holiday leave are tracked per staff member, tagged by source, and automatically exclude that person from generation on those dates.</a:t>
+            </a:r>
+          </a:p>
+        </p:txBody>
+      </p:sp>
+      <p:sp>
+        <p:nvSpPr>
+          <p:cNvPr id="8" name="TextBox 7"/>
+          <p:cNvSpPr txBox="1"/>
+          <p:nvPr/>
+        </p:nvSpPr>
+        <p:spPr>
+          <a:xfrm>
+            <a:off x="640080" y="4069080"/>
+            <a:ext cx="5425135" cy="2194560"/>
           </a:xfrm>
           <a:prstGeom prst="rect">
             <a:avLst/>
@@ -4398,7 +5069,7 @@
                 </a:solidFill>
                 <a:latin typeface="Arial"/>
               </a:rPr>
-              <a:t>Rejection returns a roster to draft with a reason, no dead ends</a:t>
+              <a:t>Bulk "public holiday" entry for every staff member in one action</a:t>
             </a:r>
           </a:p>
           <a:p>
@@ -4426,7 +5097,7 @@
                 </a:solidFill>
                 <a:latin typeface="Arial"/>
               </a:rPr>
-              <a:t>Publishing safely replaces any previously published roster for that date</a:t>
+              <a:t>HR-synced records are protected from accidental deletion</a:t>
             </a:r>
           </a:p>
           <a:p>
@@ -4454,137 +5125,7 @@
                 </a:solidFill>
                 <a:latin typeface="Arial"/>
               </a:rPr>
-              <a:t>Full approval history — published, rejected and archived — kept separately</a:t>
-            </a:r>
-          </a:p>
-        </p:txBody>
-      </p:sp>
-      <p:pic>
-        <p:nvPicPr>
-          <p:cNvPr id="7" name="Picture 6" descr="approver-inbox.png"/>
-          <p:cNvPicPr>
-            <a:picLocks noChangeAspect="1"/>
-          </p:cNvPicPr>
-          <p:nvPr/>
-        </p:nvPicPr>
-        <p:blipFill>
-          <a:blip r:embed="rId2"/>
-          <a:stretch>
-            <a:fillRect/>
-          </a:stretch>
-        </p:blipFill>
-        <p:spPr>
-          <a:xfrm>
-            <a:off x="7174597" y="822960"/>
-            <a:ext cx="3679115" cy="2606040"/>
-          </a:xfrm>
-          <a:prstGeom prst="rect">
-            <a:avLst/>
-          </a:prstGeom>
-          <a:ln w="9525">
-            <a:solidFill>
-              <a:srgbClr val="E3E1DA"/>
-            </a:solidFill>
-          </a:ln>
-          <a:effectLst/>
-        </p:spPr>
-      </p:pic>
-      <p:sp>
-        <p:nvSpPr>
-          <p:cNvPr id="8" name="TextBox 7"/>
-          <p:cNvSpPr txBox="1"/>
-          <p:nvPr/>
-        </p:nvSpPr>
-        <p:spPr>
-          <a:xfrm>
-            <a:off x="6476695" y="3483864"/>
-            <a:ext cx="5074920" cy="274320"/>
-          </a:xfrm>
-          <a:prstGeom prst="rect">
-            <a:avLst/>
-          </a:prstGeom>
-          <a:noFill/>
-        </p:spPr>
-        <p:txBody>
-          <a:bodyPr wrap="square" anchor="t">
-            <a:noAutofit/>
-          </a:bodyPr>
-          <a:lstStyle/>
-          <a:p>
-            <a:pPr algn="ctr"/>
-            <a:r>
-              <a:rPr sz="950" b="0" i="1">
-                <a:solidFill>
-                  <a:srgbClr val="6B6B6B"/>
-                </a:solidFill>
-                <a:latin typeface="Arial"/>
-              </a:rPr>
-              <a:t>Approval Inbox</a:t>
-            </a:r>
-          </a:p>
-        </p:txBody>
-      </p:sp>
-      <p:pic>
-        <p:nvPicPr>
-          <p:cNvPr id="9" name="Picture 8" descr="approver-history.png"/>
-          <p:cNvPicPr>
-            <a:picLocks noChangeAspect="1"/>
-          </p:cNvPicPr>
-          <p:nvPr/>
-        </p:nvPicPr>
-        <p:blipFill>
-          <a:blip r:embed="rId3"/>
-          <a:stretch>
-            <a:fillRect/>
-          </a:stretch>
-        </p:blipFill>
-        <p:spPr>
-          <a:xfrm>
-            <a:off x="7174597" y="3840480"/>
-            <a:ext cx="3679115" cy="2606040"/>
-          </a:xfrm>
-          <a:prstGeom prst="rect">
-            <a:avLst/>
-          </a:prstGeom>
-          <a:ln w="9525">
-            <a:solidFill>
-              <a:srgbClr val="E3E1DA"/>
-            </a:solidFill>
-          </a:ln>
-          <a:effectLst/>
-        </p:spPr>
-      </p:pic>
-      <p:sp>
-        <p:nvSpPr>
-          <p:cNvPr id="10" name="TextBox 9"/>
-          <p:cNvSpPr txBox="1"/>
-          <p:nvPr/>
-        </p:nvSpPr>
-        <p:spPr>
-          <a:xfrm>
-            <a:off x="6476695" y="6501384"/>
-            <a:ext cx="5074920" cy="274320"/>
-          </a:xfrm>
-          <a:prstGeom prst="rect">
-            <a:avLst/>
-          </a:prstGeom>
-          <a:noFill/>
-        </p:spPr>
-        <p:txBody>
-          <a:bodyPr wrap="square" anchor="t">
-            <a:noAutofit/>
-          </a:bodyPr>
-          <a:lstStyle/>
-          <a:p>
-            <a:pPr algn="ctr"/>
-            <a:r>
-              <a:rPr sz="950" b="0" i="1">
-                <a:solidFill>
-                  <a:srgbClr val="6B6B6B"/>
-                </a:solidFill>
-                <a:latin typeface="Arial"/>
-              </a:rPr>
-              <a:t>Approval History — amended vs. published, kept apart</a:t>
+              <a:t>Filterable by staff, leave type, source and date range</a:t>
             </a:r>
           </a:p>
         </p:txBody>
@@ -4651,74 +5192,9 @@
           </a:p>
         </p:txBody>
       </p:sp>
-      <p:pic>
-        <p:nvPicPr>
-          <p:cNvPr id="3" name="Picture 2" descr="staff-my-schedule.png"/>
-          <p:cNvPicPr>
-            <a:picLocks noChangeAspect="1"/>
-          </p:cNvPicPr>
-          <p:nvPr/>
-        </p:nvPicPr>
-        <p:blipFill>
-          <a:blip r:embed="rId2"/>
-          <a:stretch>
-            <a:fillRect/>
-          </a:stretch>
-        </p:blipFill>
-        <p:spPr>
-          <a:xfrm>
-            <a:off x="7985455" y="822960"/>
-            <a:ext cx="2057400" cy="4937760"/>
-          </a:xfrm>
-          <a:prstGeom prst="rect">
-            <a:avLst/>
-          </a:prstGeom>
-          <a:ln w="9525">
-            <a:solidFill>
-              <a:srgbClr val="E3E1DA"/>
-            </a:solidFill>
-          </a:ln>
-          <a:effectLst/>
-        </p:spPr>
-      </p:pic>
-      <p:sp>
-        <p:nvSpPr>
-          <p:cNvPr id="4" name="TextBox 3"/>
-          <p:cNvSpPr txBox="1"/>
-          <p:nvPr/>
-        </p:nvSpPr>
-        <p:spPr>
-          <a:xfrm>
-            <a:off x="6476695" y="5852160"/>
-            <a:ext cx="5074920" cy="457200"/>
-          </a:xfrm>
-          <a:prstGeom prst="rect">
-            <a:avLst/>
-          </a:prstGeom>
-          <a:noFill/>
-        </p:spPr>
-        <p:txBody>
-          <a:bodyPr wrap="square" anchor="t">
-            <a:noAutofit/>
-          </a:bodyPr>
-          <a:lstStyle/>
-          <a:p>
-            <a:pPr algn="ctr"/>
-            <a:r>
-              <a:rPr sz="1000" b="0" i="1">
-                <a:solidFill>
-                  <a:srgbClr val="6B6B6B"/>
-                </a:solidFill>
-                <a:latin typeface="Arial"/>
-              </a:rPr>
-              <a:t>My Schedule — an employee's own view, on their own phone</a:t>
-            </a:r>
-          </a:p>
-        </p:txBody>
-      </p:sp>
-      <p:sp>
-        <p:nvSpPr>
-          <p:cNvPr id="5" name="TextBox 4"/>
+      <p:sp>
+        <p:nvSpPr>
+          <p:cNvPr id="3" name="TextBox 2"/>
           <p:cNvSpPr txBox="1"/>
           <p:nvPr/>
         </p:nvSpPr>
@@ -4746,14 +5222,14 @@
                 </a:solidFill>
                 <a:latin typeface="Arial"/>
               </a:rPr>
-              <a:t>STAFF · MY SCHEDULE</a:t>
-            </a:r>
-          </a:p>
-        </p:txBody>
-      </p:sp>
-      <p:sp>
-        <p:nvSpPr>
-          <p:cNvPr id="6" name="TextBox 5"/>
+              <a:t>APPROVER · INBOX &amp; HISTORY</a:t>
+            </a:r>
+          </a:p>
+        </p:txBody>
+      </p:sp>
+      <p:sp>
+        <p:nvSpPr>
+          <p:cNvPr id="4" name="TextBox 3"/>
           <p:cNvSpPr txBox="1"/>
           <p:nvPr/>
         </p:nvSpPr>
@@ -4785,21 +5261,21 @@
                 </a:solidFill>
                 <a:latin typeface="Georgia"/>
               </a:rPr>
-              <a:t>Every employee can check their own shifts without asking a manager.</a:t>
-            </a:r>
-          </a:p>
-        </p:txBody>
-      </p:sp>
-      <p:sp>
-        <p:nvSpPr>
-          <p:cNvPr id="7" name="TextBox 6"/>
+              <a:t>A second pair of eyes, kept structurally separate from the drafter.</a:t>
+            </a:r>
+          </a:p>
+        </p:txBody>
+      </p:sp>
+      <p:sp>
+        <p:nvSpPr>
+          <p:cNvPr id="5" name="TextBox 4"/>
           <p:cNvSpPr txBox="1"/>
           <p:nvPr/>
         </p:nvSpPr>
         <p:spPr>
           <a:xfrm>
             <a:off x="640080" y="2331720"/>
-            <a:ext cx="5425135" cy="1600200"/>
+            <a:ext cx="5425135" cy="1737360"/>
           </a:xfrm>
           <a:prstGeom prst="rect">
             <a:avLst/>
@@ -4824,21 +5300,21 @@
                 </a:solidFill>
                 <a:latin typeface="Arial"/>
               </a:rPr>
-              <a:t>Once a roster is published, each staff member with a linked account sees their own upcoming shifts — shift name, VIC flag and duration — grouped by day, on a mobile-first layout built for checking on the go.</a:t>
-            </a:r>
-          </a:p>
-        </p:txBody>
-      </p:sp>
-      <p:sp>
-        <p:nvSpPr>
-          <p:cNvPr id="8" name="TextBox 7"/>
-          <p:cNvSpPr txBox="1"/>
-          <p:nvPr/>
-        </p:nvSpPr>
-        <p:spPr>
-          <a:xfrm>
-            <a:off x="640080" y="4069080"/>
-            <a:ext cx="5425135" cy="2194560"/>
+              <a:t>Approvers get a dedicated inbox of submitted rosters — score, overrides and full shift detail — with approve, reject (with a note back to the admin) and publish.</a:t>
+            </a:r>
+          </a:p>
+        </p:txBody>
+      </p:sp>
+      <p:sp>
+        <p:nvSpPr>
+          <p:cNvPr id="6" name="TextBox 5"/>
+          <p:cNvSpPr txBox="1"/>
+          <p:nvPr/>
+        </p:nvSpPr>
+        <p:spPr>
+          <a:xfrm>
+            <a:off x="640080" y="4160520"/>
+            <a:ext cx="5425135" cy="2103120"/>
           </a:xfrm>
           <a:prstGeom prst="rect">
             <a:avLst/>
@@ -4875,7 +5351,7 @@
                 </a:solidFill>
                 <a:latin typeface="Arial"/>
               </a:rPr>
-              <a:t>Reads only published rosters — never a draft in progress</a:t>
+              <a:t>Rejection returns a roster to draft with a reason, no dead ends</a:t>
             </a:r>
           </a:p>
           <a:p>
@@ -4903,7 +5379,7 @@
                 </a:solidFill>
                 <a:latin typeface="Arial"/>
               </a:rPr>
-              <a:t>No admin or approver access required, just a linked staff record</a:t>
+              <a:t>Publishing safely replaces any previously published roster for that date</a:t>
             </a:r>
           </a:p>
           <a:p>
@@ -4931,7 +5407,137 @@
                 </a:solidFill>
                 <a:latin typeface="Arial"/>
               </a:rPr>
-              <a:t>Leave requests and a team view are scoped for a later phase</a:t>
+              <a:t>Full approval history — published, rejected and archived — kept separately</a:t>
+            </a:r>
+          </a:p>
+        </p:txBody>
+      </p:sp>
+      <p:pic>
+        <p:nvPicPr>
+          <p:cNvPr id="7" name="Picture 6" descr="approver-inbox.png"/>
+          <p:cNvPicPr>
+            <a:picLocks noChangeAspect="1"/>
+          </p:cNvPicPr>
+          <p:nvPr/>
+        </p:nvPicPr>
+        <p:blipFill>
+          <a:blip r:embed="rId2"/>
+          <a:stretch>
+            <a:fillRect/>
+          </a:stretch>
+        </p:blipFill>
+        <p:spPr>
+          <a:xfrm>
+            <a:off x="7174597" y="822960"/>
+            <a:ext cx="3679115" cy="2606040"/>
+          </a:xfrm>
+          <a:prstGeom prst="rect">
+            <a:avLst/>
+          </a:prstGeom>
+          <a:ln w="9525">
+            <a:solidFill>
+              <a:srgbClr val="E3E1DA"/>
+            </a:solidFill>
+          </a:ln>
+          <a:effectLst/>
+        </p:spPr>
+      </p:pic>
+      <p:sp>
+        <p:nvSpPr>
+          <p:cNvPr id="8" name="TextBox 7"/>
+          <p:cNvSpPr txBox="1"/>
+          <p:nvPr/>
+        </p:nvSpPr>
+        <p:spPr>
+          <a:xfrm>
+            <a:off x="6476695" y="3483864"/>
+            <a:ext cx="5074920" cy="274320"/>
+          </a:xfrm>
+          <a:prstGeom prst="rect">
+            <a:avLst/>
+          </a:prstGeom>
+          <a:noFill/>
+        </p:spPr>
+        <p:txBody>
+          <a:bodyPr wrap="square" anchor="t">
+            <a:noAutofit/>
+          </a:bodyPr>
+          <a:lstStyle/>
+          <a:p>
+            <a:pPr algn="ctr"/>
+            <a:r>
+              <a:rPr sz="950" b="0" i="1">
+                <a:solidFill>
+                  <a:srgbClr val="6B6B6B"/>
+                </a:solidFill>
+                <a:latin typeface="Arial"/>
+              </a:rPr>
+              <a:t>Approval Inbox</a:t>
+            </a:r>
+          </a:p>
+        </p:txBody>
+      </p:sp>
+      <p:pic>
+        <p:nvPicPr>
+          <p:cNvPr id="9" name="Picture 8" descr="approver-history.png"/>
+          <p:cNvPicPr>
+            <a:picLocks noChangeAspect="1"/>
+          </p:cNvPicPr>
+          <p:nvPr/>
+        </p:nvPicPr>
+        <p:blipFill>
+          <a:blip r:embed="rId3"/>
+          <a:stretch>
+            <a:fillRect/>
+          </a:stretch>
+        </p:blipFill>
+        <p:spPr>
+          <a:xfrm>
+            <a:off x="7174597" y="3840480"/>
+            <a:ext cx="3679115" cy="2606040"/>
+          </a:xfrm>
+          <a:prstGeom prst="rect">
+            <a:avLst/>
+          </a:prstGeom>
+          <a:ln w="9525">
+            <a:solidFill>
+              <a:srgbClr val="E3E1DA"/>
+            </a:solidFill>
+          </a:ln>
+          <a:effectLst/>
+        </p:spPr>
+      </p:pic>
+      <p:sp>
+        <p:nvSpPr>
+          <p:cNvPr id="10" name="TextBox 9"/>
+          <p:cNvSpPr txBox="1"/>
+          <p:nvPr/>
+        </p:nvSpPr>
+        <p:spPr>
+          <a:xfrm>
+            <a:off x="6476695" y="6501384"/>
+            <a:ext cx="5074920" cy="274320"/>
+          </a:xfrm>
+          <a:prstGeom prst="rect">
+            <a:avLst/>
+          </a:prstGeom>
+          <a:noFill/>
+        </p:spPr>
+        <p:txBody>
+          <a:bodyPr wrap="square" anchor="t">
+            <a:noAutofit/>
+          </a:bodyPr>
+          <a:lstStyle/>
+          <a:p>
+            <a:pPr algn="ctr"/>
+            <a:r>
+              <a:rPr sz="950" b="0" i="1">
+                <a:solidFill>
+                  <a:srgbClr val="6B6B6B"/>
+                </a:solidFill>
+                <a:latin typeface="Arial"/>
+              </a:rPr>
+              <a:t>Approval History — amended vs. published, kept apart</a:t>
             </a:r>
           </a:p>
         </p:txBody>
@@ -4969,6 +5575,700 @@
             <a:avLst/>
           </a:prstGeom>
           <a:solidFill>
+            <a:srgbClr val="FFFFFF"/>
+          </a:solidFill>
+          <a:ln>
+            <a:noFill/>
+          </a:ln>
+          <a:effectLst/>
+        </p:spPr>
+        <p:style>
+          <a:lnRef idx="1">
+            <a:schemeClr val="accent1"/>
+          </a:lnRef>
+          <a:fillRef idx="3">
+            <a:schemeClr val="accent1"/>
+          </a:fillRef>
+          <a:effectRef idx="2">
+            <a:schemeClr val="accent1"/>
+          </a:effectRef>
+          <a:fontRef idx="minor">
+            <a:schemeClr val="lt1"/>
+          </a:fontRef>
+        </p:style>
+        <p:txBody>
+          <a:bodyPr rtlCol="0" anchor="ctr"/>
+          <a:lstStyle/>
+          <a:p>
+            <a:pPr algn="ctr"/>
+          </a:p>
+        </p:txBody>
+      </p:sp>
+      <p:pic>
+        <p:nvPicPr>
+          <p:cNvPr id="3" name="Picture 2" descr="staff-my-schedule.png"/>
+          <p:cNvPicPr>
+            <a:picLocks noChangeAspect="1"/>
+          </p:cNvPicPr>
+          <p:nvPr/>
+        </p:nvPicPr>
+        <p:blipFill>
+          <a:blip r:embed="rId2"/>
+          <a:stretch>
+            <a:fillRect/>
+          </a:stretch>
+        </p:blipFill>
+        <p:spPr>
+          <a:xfrm>
+            <a:off x="7985455" y="822960"/>
+            <a:ext cx="2057400" cy="4937760"/>
+          </a:xfrm>
+          <a:prstGeom prst="rect">
+            <a:avLst/>
+          </a:prstGeom>
+          <a:ln w="9525">
+            <a:solidFill>
+              <a:srgbClr val="E3E1DA"/>
+            </a:solidFill>
+          </a:ln>
+          <a:effectLst/>
+        </p:spPr>
+      </p:pic>
+      <p:sp>
+        <p:nvSpPr>
+          <p:cNvPr id="4" name="TextBox 3"/>
+          <p:cNvSpPr txBox="1"/>
+          <p:nvPr/>
+        </p:nvSpPr>
+        <p:spPr>
+          <a:xfrm>
+            <a:off x="6476695" y="5852160"/>
+            <a:ext cx="5074920" cy="457200"/>
+          </a:xfrm>
+          <a:prstGeom prst="rect">
+            <a:avLst/>
+          </a:prstGeom>
+          <a:noFill/>
+        </p:spPr>
+        <p:txBody>
+          <a:bodyPr wrap="square" anchor="t">
+            <a:noAutofit/>
+          </a:bodyPr>
+          <a:lstStyle/>
+          <a:p>
+            <a:pPr algn="ctr"/>
+            <a:r>
+              <a:rPr sz="1000" b="0" i="1">
+                <a:solidFill>
+                  <a:srgbClr val="6B6B6B"/>
+                </a:solidFill>
+                <a:latin typeface="Arial"/>
+              </a:rPr>
+              <a:t>My Schedule — an employee's own view, on their own phone</a:t>
+            </a:r>
+          </a:p>
+        </p:txBody>
+      </p:sp>
+      <p:sp>
+        <p:nvSpPr>
+          <p:cNvPr id="5" name="TextBox 4"/>
+          <p:cNvSpPr txBox="1"/>
+          <p:nvPr/>
+        </p:nvSpPr>
+        <p:spPr>
+          <a:xfrm>
+            <a:off x="640080" y="685800"/>
+            <a:ext cx="5425135" cy="320040"/>
+          </a:xfrm>
+          <a:prstGeom prst="rect">
+            <a:avLst/>
+          </a:prstGeom>
+          <a:noFill/>
+        </p:spPr>
+        <p:txBody>
+          <a:bodyPr wrap="square" anchor="t">
+            <a:noAutofit/>
+          </a:bodyPr>
+          <a:lstStyle/>
+          <a:p>
+            <a:pPr algn="l"/>
+            <a:r>
+              <a:rPr sz="1050" b="1" i="0">
+                <a:solidFill>
+                  <a:srgbClr val="C9A84C"/>
+                </a:solidFill>
+                <a:latin typeface="Arial"/>
+              </a:rPr>
+              <a:t>STAFF · MY SCHEDULE</a:t>
+            </a:r>
+          </a:p>
+        </p:txBody>
+      </p:sp>
+      <p:sp>
+        <p:nvSpPr>
+          <p:cNvPr id="6" name="TextBox 5"/>
+          <p:cNvSpPr txBox="1"/>
+          <p:nvPr/>
+        </p:nvSpPr>
+        <p:spPr>
+          <a:xfrm>
+            <a:off x="640080" y="1024128"/>
+            <a:ext cx="5425135" cy="1234440"/>
+          </a:xfrm>
+          <a:prstGeom prst="rect">
+            <a:avLst/>
+          </a:prstGeom>
+          <a:noFill/>
+        </p:spPr>
+        <p:txBody>
+          <a:bodyPr wrap="square" anchor="t">
+            <a:noAutofit/>
+          </a:bodyPr>
+          <a:lstStyle/>
+          <a:p>
+            <a:pPr algn="l">
+              <a:lnSpc>
+                <a:spcPct val="115000"/>
+              </a:lnSpc>
+            </a:pPr>
+            <a:r>
+              <a:rPr sz="2100" b="0" i="0">
+                <a:solidFill>
+                  <a:srgbClr val="1E2761"/>
+                </a:solidFill>
+                <a:latin typeface="Georgia"/>
+              </a:rPr>
+              <a:t>Every employee can check their own shifts without asking a manager.</a:t>
+            </a:r>
+          </a:p>
+        </p:txBody>
+      </p:sp>
+      <p:sp>
+        <p:nvSpPr>
+          <p:cNvPr id="7" name="TextBox 6"/>
+          <p:cNvSpPr txBox="1"/>
+          <p:nvPr/>
+        </p:nvSpPr>
+        <p:spPr>
+          <a:xfrm>
+            <a:off x="640080" y="2331720"/>
+            <a:ext cx="5425135" cy="1600200"/>
+          </a:xfrm>
+          <a:prstGeom prst="rect">
+            <a:avLst/>
+          </a:prstGeom>
+          <a:noFill/>
+        </p:spPr>
+        <p:txBody>
+          <a:bodyPr wrap="square" anchor="t">
+            <a:noAutofit/>
+          </a:bodyPr>
+          <a:lstStyle/>
+          <a:p>
+            <a:pPr algn="l">
+              <a:lnSpc>
+                <a:spcPct val="132000"/>
+              </a:lnSpc>
+            </a:pPr>
+            <a:r>
+              <a:rPr sz="1200" b="0" i="0">
+                <a:solidFill>
+                  <a:srgbClr val="6B6B6B"/>
+                </a:solidFill>
+                <a:latin typeface="Arial"/>
+              </a:rPr>
+              <a:t>Once a roster is published, each staff member with a linked account sees their own upcoming shifts — shift name, VIC flag and duration — grouped by day, on a mobile-first layout built for checking on the go.</a:t>
+            </a:r>
+          </a:p>
+        </p:txBody>
+      </p:sp>
+      <p:sp>
+        <p:nvSpPr>
+          <p:cNvPr id="8" name="TextBox 7"/>
+          <p:cNvSpPr txBox="1"/>
+          <p:nvPr/>
+        </p:nvSpPr>
+        <p:spPr>
+          <a:xfrm>
+            <a:off x="640080" y="4069080"/>
+            <a:ext cx="5425135" cy="2194560"/>
+          </a:xfrm>
+          <a:prstGeom prst="rect">
+            <a:avLst/>
+          </a:prstGeom>
+          <a:noFill/>
+        </p:spPr>
+        <p:txBody>
+          <a:bodyPr wrap="square">
+            <a:noAutofit/>
+          </a:bodyPr>
+          <a:lstStyle/>
+          <a:p>
+            <a:pPr>
+              <a:lnSpc>
+                <a:spcPct val="118000"/>
+              </a:lnSpc>
+              <a:spcAft>
+                <a:spcPts val="900"/>
+              </a:spcAft>
+            </a:pPr>
+            <a:r>
+              <a:rPr sz="1150">
+                <a:solidFill>
+                  <a:srgbClr val="C9A84C"/>
+                </a:solidFill>
+                <a:latin typeface="Arial"/>
+              </a:rPr>
+              <a:t>✦  </a:t>
+            </a:r>
+            <a:r>
+              <a:rPr sz="1150">
+                <a:solidFill>
+                  <a:srgbClr val="1A1A1A"/>
+                </a:solidFill>
+                <a:latin typeface="Arial"/>
+              </a:rPr>
+              <a:t>Reads only published rosters — never a draft in progress</a:t>
+            </a:r>
+          </a:p>
+          <a:p>
+            <a:pPr>
+              <a:lnSpc>
+                <a:spcPct val="118000"/>
+              </a:lnSpc>
+              <a:spcAft>
+                <a:spcPts val="900"/>
+              </a:spcAft>
+            </a:pPr>
+            <a:r>
+              <a:rPr sz="1150">
+                <a:solidFill>
+                  <a:srgbClr val="C9A84C"/>
+                </a:solidFill>
+                <a:latin typeface="Arial"/>
+              </a:rPr>
+              <a:t>✦  </a:t>
+            </a:r>
+            <a:r>
+              <a:rPr sz="1150">
+                <a:solidFill>
+                  <a:srgbClr val="1A1A1A"/>
+                </a:solidFill>
+                <a:latin typeface="Arial"/>
+              </a:rPr>
+              <a:t>No admin or approver access required, just a linked staff record</a:t>
+            </a:r>
+          </a:p>
+          <a:p>
+            <a:pPr>
+              <a:lnSpc>
+                <a:spcPct val="118000"/>
+              </a:lnSpc>
+              <a:spcAft>
+                <a:spcPts val="900"/>
+              </a:spcAft>
+            </a:pPr>
+            <a:r>
+              <a:rPr sz="1150">
+                <a:solidFill>
+                  <a:srgbClr val="C9A84C"/>
+                </a:solidFill>
+                <a:latin typeface="Arial"/>
+              </a:rPr>
+              <a:t>✦  </a:t>
+            </a:r>
+            <a:r>
+              <a:rPr sz="1150">
+                <a:solidFill>
+                  <a:srgbClr val="1A1A1A"/>
+                </a:solidFill>
+                <a:latin typeface="Arial"/>
+              </a:rPr>
+              <a:t>Leave requests and a team view are scoped for a later phase</a:t>
+            </a:r>
+          </a:p>
+        </p:txBody>
+      </p:sp>
+    </p:spTree>
+  </p:cSld>
+  <p:clrMapOvr>
+    <a:masterClrMapping/>
+  </p:clrMapOvr>
+</p:sld>
+</file>
+
+<file path=ppt/slides/slide15.xml><?xml version="1.0" encoding="utf-8"?>
+<p:sld xmlns:a="http://schemas.openxmlformats.org/drawingml/2006/main" xmlns:p="http://schemas.openxmlformats.org/presentationml/2006/main" xmlns:r="http://schemas.openxmlformats.org/officeDocument/2006/relationships">
+  <p:cSld>
+    <p:spTree>
+      <p:nvGrpSpPr>
+        <p:cNvPr id="1" name=""/>
+        <p:cNvGrpSpPr/>
+        <p:nvPr/>
+      </p:nvGrpSpPr>
+      <p:grpSpPr/>
+      <p:sp>
+        <p:nvSpPr>
+          <p:cNvPr id="2" name="Rectangle 1"/>
+          <p:cNvSpPr/>
+          <p:nvPr/>
+        </p:nvSpPr>
+        <p:spPr>
+          <a:xfrm>
+            <a:off x="0" y="0"/>
+            <a:ext cx="12191695" cy="6858000"/>
+          </a:xfrm>
+          <a:prstGeom prst="rect">
+            <a:avLst/>
+          </a:prstGeom>
+          <a:solidFill>
+            <a:srgbClr val="FFFFFF"/>
+          </a:solidFill>
+          <a:ln>
+            <a:noFill/>
+          </a:ln>
+          <a:effectLst/>
+        </p:spPr>
+        <p:style>
+          <a:lnRef idx="1">
+            <a:schemeClr val="accent1"/>
+          </a:lnRef>
+          <a:fillRef idx="3">
+            <a:schemeClr val="accent1"/>
+          </a:fillRef>
+          <a:effectRef idx="2">
+            <a:schemeClr val="accent1"/>
+          </a:effectRef>
+          <a:fontRef idx="minor">
+            <a:schemeClr val="lt1"/>
+          </a:fontRef>
+        </p:style>
+        <p:txBody>
+          <a:bodyPr rtlCol="0" anchor="ctr"/>
+          <a:lstStyle/>
+          <a:p>
+            <a:pPr algn="ctr"/>
+          </a:p>
+        </p:txBody>
+      </p:sp>
+      <p:pic>
+        <p:nvPicPr>
+          <p:cNvPr id="3" name="Picture 2" descr="reader-detail.png"/>
+          <p:cNvPicPr>
+            <a:picLocks noChangeAspect="1"/>
+          </p:cNvPicPr>
+          <p:nvPr/>
+        </p:nvPicPr>
+        <p:blipFill>
+          <a:blip r:embed="rId2"/>
+          <a:stretch>
+            <a:fillRect/>
+          </a:stretch>
+        </p:blipFill>
+        <p:spPr>
+          <a:xfrm>
+            <a:off x="640080" y="822960"/>
+            <a:ext cx="5074920" cy="3594735"/>
+          </a:xfrm>
+          <a:prstGeom prst="rect">
+            <a:avLst/>
+          </a:prstGeom>
+          <a:ln w="9525">
+            <a:solidFill>
+              <a:srgbClr val="E3E1DA"/>
+            </a:solidFill>
+          </a:ln>
+          <a:effectLst/>
+        </p:spPr>
+      </p:pic>
+      <p:sp>
+        <p:nvSpPr>
+          <p:cNvPr id="4" name="TextBox 3"/>
+          <p:cNvSpPr txBox="1"/>
+          <p:nvPr/>
+        </p:nvSpPr>
+        <p:spPr>
+          <a:xfrm>
+            <a:off x="640080" y="4509135"/>
+            <a:ext cx="5074920" cy="457200"/>
+          </a:xfrm>
+          <a:prstGeom prst="rect">
+            <a:avLst/>
+          </a:prstGeom>
+          <a:noFill/>
+        </p:spPr>
+        <p:txBody>
+          <a:bodyPr wrap="square" anchor="t">
+            <a:noAutofit/>
+          </a:bodyPr>
+          <a:lstStyle/>
+          <a:p>
+            <a:pPr algn="ctr"/>
+            <a:r>
+              <a:rPr sz="1000" b="0" i="1">
+                <a:solidFill>
+                  <a:srgbClr val="6B6B6B"/>
+                </a:solidFill>
+                <a:latin typeface="Arial"/>
+              </a:rPr>
+              <a:t>Read-only roster detail, with CSV and PDF export on every row</a:t>
+            </a:r>
+          </a:p>
+        </p:txBody>
+      </p:sp>
+      <p:sp>
+        <p:nvSpPr>
+          <p:cNvPr id="5" name="TextBox 4"/>
+          <p:cNvSpPr txBox="1"/>
+          <p:nvPr/>
+        </p:nvSpPr>
+        <p:spPr>
+          <a:xfrm>
+            <a:off x="6126480" y="685800"/>
+            <a:ext cx="5425135" cy="320040"/>
+          </a:xfrm>
+          <a:prstGeom prst="rect">
+            <a:avLst/>
+          </a:prstGeom>
+          <a:noFill/>
+        </p:spPr>
+        <p:txBody>
+          <a:bodyPr wrap="square" anchor="t">
+            <a:noAutofit/>
+          </a:bodyPr>
+          <a:lstStyle/>
+          <a:p>
+            <a:pPr algn="l"/>
+            <a:r>
+              <a:rPr sz="1050" b="1" i="0">
+                <a:solidFill>
+                  <a:srgbClr val="C9A84C"/>
+                </a:solidFill>
+                <a:latin typeface="Arial"/>
+              </a:rPr>
+              <a:t>READER · PUBLISHED ROSTERS</a:t>
+            </a:r>
+          </a:p>
+        </p:txBody>
+      </p:sp>
+      <p:sp>
+        <p:nvSpPr>
+          <p:cNvPr id="6" name="TextBox 5"/>
+          <p:cNvSpPr txBox="1"/>
+          <p:nvPr/>
+        </p:nvSpPr>
+        <p:spPr>
+          <a:xfrm>
+            <a:off x="6126480" y="1024128"/>
+            <a:ext cx="5425135" cy="1234440"/>
+          </a:xfrm>
+          <a:prstGeom prst="rect">
+            <a:avLst/>
+          </a:prstGeom>
+          <a:noFill/>
+        </p:spPr>
+        <p:txBody>
+          <a:bodyPr wrap="square" anchor="t">
+            <a:noAutofit/>
+          </a:bodyPr>
+          <a:lstStyle/>
+          <a:p>
+            <a:pPr algn="l">
+              <a:lnSpc>
+                <a:spcPct val="115000"/>
+              </a:lnSpc>
+            </a:pPr>
+            <a:r>
+              <a:rPr sz="2100" b="0" i="0">
+                <a:solidFill>
+                  <a:srgbClr val="1E2761"/>
+                </a:solidFill>
+                <a:latin typeface="Georgia"/>
+              </a:rPr>
+              <a:t>A shared screen or a printout, without a spreadsheet in between.</a:t>
+            </a:r>
+          </a:p>
+        </p:txBody>
+      </p:sp>
+      <p:sp>
+        <p:nvSpPr>
+          <p:cNvPr id="7" name="TextBox 6"/>
+          <p:cNvSpPr txBox="1"/>
+          <p:nvPr/>
+        </p:nvSpPr>
+        <p:spPr>
+          <a:xfrm>
+            <a:off x="6126480" y="2331720"/>
+            <a:ext cx="5425135" cy="1600200"/>
+          </a:xfrm>
+          <a:prstGeom prst="rect">
+            <a:avLst/>
+          </a:prstGeom>
+          <a:noFill/>
+        </p:spPr>
+        <p:txBody>
+          <a:bodyPr wrap="square" anchor="t">
+            <a:noAutofit/>
+          </a:bodyPr>
+          <a:lstStyle/>
+          <a:p>
+            <a:pPr algn="l">
+              <a:lnSpc>
+                <a:spcPct val="132000"/>
+              </a:lnSpc>
+            </a:pPr>
+            <a:r>
+              <a:rPr sz="1200" b="0" i="0">
+                <a:solidFill>
+                  <a:srgbClr val="6B6B6B"/>
+                </a:solidFill>
+                <a:latin typeface="Arial"/>
+              </a:rPr>
+              <a:t>Lists every published roster for its boutique and expands to the identical staff-mix and rule-flag detail view admins and approvers see, minus any edit controls. Every row exports straight to CSV or a print-ready PDF.</a:t>
+            </a:r>
+          </a:p>
+        </p:txBody>
+      </p:sp>
+      <p:sp>
+        <p:nvSpPr>
+          <p:cNvPr id="8" name="TextBox 7"/>
+          <p:cNvSpPr txBox="1"/>
+          <p:nvPr/>
+        </p:nvSpPr>
+        <p:spPr>
+          <a:xfrm>
+            <a:off x="6126480" y="4069080"/>
+            <a:ext cx="5425135" cy="2194560"/>
+          </a:xfrm>
+          <a:prstGeom prst="rect">
+            <a:avLst/>
+          </a:prstGeom>
+          <a:noFill/>
+        </p:spPr>
+        <p:txBody>
+          <a:bodyPr wrap="square">
+            <a:noAutofit/>
+          </a:bodyPr>
+          <a:lstStyle/>
+          <a:p>
+            <a:pPr>
+              <a:lnSpc>
+                <a:spcPct val="118000"/>
+              </a:lnSpc>
+              <a:spcAft>
+                <a:spcPts val="900"/>
+              </a:spcAft>
+            </a:pPr>
+            <a:r>
+              <a:rPr sz="1150">
+                <a:solidFill>
+                  <a:srgbClr val="C9A84C"/>
+                </a:solidFill>
+                <a:latin typeface="Arial"/>
+              </a:rPr>
+              <a:t>✦  </a:t>
+            </a:r>
+            <a:r>
+              <a:rPr sz="1150">
+                <a:solidFill>
+                  <a:srgbClr val="1A1A1A"/>
+                </a:solidFill>
+                <a:latin typeface="Arial"/>
+              </a:rPr>
+              <a:t>Shows published rosters only — drafts and pending approvals stay invisible</a:t>
+            </a:r>
+          </a:p>
+          <a:p>
+            <a:pPr>
+              <a:lnSpc>
+                <a:spcPct val="118000"/>
+              </a:lnSpc>
+              <a:spcAft>
+                <a:spcPts val="900"/>
+              </a:spcAft>
+            </a:pPr>
+            <a:r>
+              <a:rPr sz="1150">
+                <a:solidFill>
+                  <a:srgbClr val="C9A84C"/>
+                </a:solidFill>
+                <a:latin typeface="Arial"/>
+              </a:rPr>
+              <a:t>✦  </a:t>
+            </a:r>
+            <a:r>
+              <a:rPr sz="1150">
+                <a:solidFill>
+                  <a:srgbClr val="1A1A1A"/>
+                </a:solidFill>
+                <a:latin typeface="Arial"/>
+              </a:rPr>
+              <a:t>One-click CSV export for downstream systems, PDF for printing or a shared screen</a:t>
+            </a:r>
+          </a:p>
+          <a:p>
+            <a:pPr>
+              <a:lnSpc>
+                <a:spcPct val="118000"/>
+              </a:lnSpc>
+              <a:spcAft>
+                <a:spcPts val="900"/>
+              </a:spcAft>
+            </a:pPr>
+            <a:r>
+              <a:rPr sz="1150">
+                <a:solidFill>
+                  <a:srgbClr val="C9A84C"/>
+                </a:solidFill>
+                <a:latin typeface="Arial"/>
+              </a:rPr>
+              <a:t>✦  </a:t>
+            </a:r>
+            <a:r>
+              <a:rPr sz="1150">
+                <a:solidFill>
+                  <a:srgbClr val="1A1A1A"/>
+                </a:solidFill>
+                <a:latin typeface="Arial"/>
+              </a:rPr>
+              <a:t>No admin or approver access required — a login scoped to one boutique, read-only</a:t>
+            </a:r>
+          </a:p>
+        </p:txBody>
+      </p:sp>
+    </p:spTree>
+  </p:cSld>
+  <p:clrMapOvr>
+    <a:masterClrMapping/>
+  </p:clrMapOvr>
+</p:sld>
+</file>
+
+<file path=ppt/slides/slide16.xml><?xml version="1.0" encoding="utf-8"?>
+<p:sld xmlns:a="http://schemas.openxmlformats.org/drawingml/2006/main" xmlns:p="http://schemas.openxmlformats.org/presentationml/2006/main" xmlns:r="http://schemas.openxmlformats.org/officeDocument/2006/relationships">
+  <p:cSld>
+    <p:spTree>
+      <p:nvGrpSpPr>
+        <p:cNvPr id="1" name=""/>
+        <p:cNvGrpSpPr/>
+        <p:nvPr/>
+      </p:nvGrpSpPr>
+      <p:grpSpPr/>
+      <p:sp>
+        <p:nvSpPr>
+          <p:cNvPr id="2" name="Rectangle 1"/>
+          <p:cNvSpPr/>
+          <p:nvPr/>
+        </p:nvSpPr>
+        <p:spPr>
+          <a:xfrm>
+            <a:off x="0" y="0"/>
+            <a:ext cx="12191695" cy="6858000"/>
+          </a:xfrm>
+          <a:prstGeom prst="rect">
+            <a:avLst/>
+          </a:prstGeom>
+          <a:solidFill>
             <a:srgbClr val="F5F0E8"/>
           </a:solidFill>
           <a:ln>
@@ -6033,7 +7333,7 @@
 </p:sld>
 </file>
 
-<file path=ppt/slides/slide15.xml><?xml version="1.0" encoding="utf-8"?>
+<file path=ppt/slides/slide17.xml><?xml version="1.0" encoding="utf-8"?>
 <p:sld xmlns:a="http://schemas.openxmlformats.org/drawingml/2006/main" xmlns:p="http://schemas.openxmlformats.org/presentationml/2006/main" xmlns:r="http://schemas.openxmlformats.org/officeDocument/2006/relationships">
   <p:cSld>
     <p:spTree>
@@ -6726,7 +8026,7 @@
                           </a:solidFill>
                           <a:latin typeface="Arial"/>
                         </a:rPr>
-                        <a:t>Published Rosters — planned</a:t>
+                        <a:t>Published Rosters</a:t>
                       </a:r>
                     </a:p>
                   </a:txBody>
@@ -6780,7 +8080,7 @@
                           </a:solidFill>
                           <a:latin typeface="Arial"/>
                         </a:rPr>
-                        <a:t>Printed roster taped to a wall</a:t>
+                        <a:t>Printed roster taped to a wall, manual CSV exports</a:t>
                       </a:r>
                     </a:p>
                   </a:txBody>
@@ -6807,7 +8107,7 @@
                           </a:solidFill>
                           <a:latin typeface="Arial"/>
                         </a:rPr>
-                        <a:t>Always-current view with no reprint cycle once delivered</a:t>
+                        <a:t>Always-current view, plus one-click CSV/PDF export, with no reprint cycle</a:t>
                       </a:r>
                     </a:p>
                   </a:txBody>
@@ -7274,7 +8574,7 @@
 </p:sld>
 </file>
 
-<file path=ppt/slides/slide16.xml><?xml version="1.0" encoding="utf-8"?>
+<file path=ppt/slides/slide18.xml><?xml version="1.0" encoding="utf-8"?>
 <p:sld xmlns:a="http://schemas.openxmlformats.org/drawingml/2006/main" xmlns:p="http://schemas.openxmlformats.org/presentationml/2006/main" xmlns:r="http://schemas.openxmlformats.org/officeDocument/2006/relationships">
   <p:cSld>
     <p:spTree>
@@ -7442,7 +8742,7 @@
         <p:spPr>
           <a:xfrm>
             <a:off x="640080" y="2286000"/>
-            <a:ext cx="3454298" cy="2377440"/>
+            <a:ext cx="5318607" cy="2011680"/>
           </a:xfrm>
           <a:prstGeom prst="roundRect">
             <a:avLst>
@@ -7547,7 +8847,7 @@
         <p:spPr>
           <a:xfrm>
             <a:off x="868680" y="2971800"/>
-            <a:ext cx="2997098" cy="731520"/>
+            <a:ext cx="4861407" cy="731520"/>
           </a:xfrm>
           <a:prstGeom prst="rect">
             <a:avLst/>
@@ -7586,7 +8886,7 @@
         <p:spPr>
           <a:xfrm>
             <a:off x="868680" y="3703320"/>
-            <a:ext cx="2997098" cy="822960"/>
+            <a:ext cx="4861407" cy="822960"/>
           </a:xfrm>
           <a:prstGeom prst="rect">
             <a:avLst/>
@@ -7624,8 +8924,8 @@
         </p:nvSpPr>
         <p:spPr>
           <a:xfrm>
-            <a:off x="4368698" y="2286000"/>
-            <a:ext cx="3454298" cy="2377440"/>
+            <a:off x="6233007" y="2286000"/>
+            <a:ext cx="5318607" cy="2011680"/>
           </a:xfrm>
           <a:prstGeom prst="roundRect">
             <a:avLst>
@@ -7672,7 +8972,7 @@
         </p:nvSpPr>
         <p:spPr>
           <a:xfrm>
-            <a:off x="4597298" y="2514600"/>
+            <a:off x="6461607" y="2514600"/>
             <a:ext cx="636422" cy="256032"/>
           </a:xfrm>
           <a:prstGeom prst="roundRect">
@@ -7729,8 +9029,8 @@
         </p:nvSpPr>
         <p:spPr>
           <a:xfrm>
-            <a:off x="4597298" y="2971800"/>
-            <a:ext cx="2997098" cy="731520"/>
+            <a:off x="6461607" y="2971800"/>
+            <a:ext cx="4861407" cy="731520"/>
           </a:xfrm>
           <a:prstGeom prst="rect">
             <a:avLst/>
@@ -7768,8 +9068,8 @@
         </p:nvSpPr>
         <p:spPr>
           <a:xfrm>
-            <a:off x="4597298" y="3703320"/>
-            <a:ext cx="2997098" cy="822960"/>
+            <a:off x="6461607" y="3703320"/>
+            <a:ext cx="4861407" cy="822960"/>
           </a:xfrm>
           <a:prstGeom prst="rect">
             <a:avLst/>
@@ -7795,189 +9095,6 @@
                 <a:latin typeface="Arial"/>
               </a:rPr>
               <a:t>Let staff see the published roster for their whole boutique, not just their own shifts.</a:t>
-            </a:r>
-          </a:p>
-        </p:txBody>
-      </p:sp>
-      <p:sp>
-        <p:nvSpPr>
-          <p:cNvPr id="14" name="Rounded Rectangle 13"/>
-          <p:cNvSpPr/>
-          <p:nvPr/>
-        </p:nvSpPr>
-        <p:spPr>
-          <a:xfrm>
-            <a:off x="8097316" y="2286000"/>
-            <a:ext cx="3454298" cy="2377440"/>
-          </a:xfrm>
-          <a:prstGeom prst="roundRect">
-            <a:avLst>
-              <a:gd name="adj" fmla="val 6000"/>
-            </a:avLst>
-          </a:prstGeom>
-          <a:solidFill>
-            <a:srgbClr val="FFFFFF"/>
-          </a:solidFill>
-          <a:ln w="9525">
-            <a:solidFill>
-              <a:srgbClr val="E3E1DA"/>
-            </a:solidFill>
-          </a:ln>
-          <a:effectLst/>
-        </p:spPr>
-        <p:style>
-          <a:lnRef idx="1">
-            <a:schemeClr val="accent1"/>
-          </a:lnRef>
-          <a:fillRef idx="3">
-            <a:schemeClr val="accent1"/>
-          </a:fillRef>
-          <a:effectRef idx="2">
-            <a:schemeClr val="accent1"/>
-          </a:effectRef>
-          <a:fontRef idx="minor">
-            <a:schemeClr val="lt1"/>
-          </a:fontRef>
-        </p:style>
-        <p:txBody>
-          <a:bodyPr rtlCol="0" anchor="ctr"/>
-          <a:lstStyle/>
-          <a:p>
-            <a:pPr algn="ctr"/>
-          </a:p>
-        </p:txBody>
-      </p:sp>
-      <p:sp>
-        <p:nvSpPr>
-          <p:cNvPr id="15" name="Rounded Rectangle 14"/>
-          <p:cNvSpPr/>
-          <p:nvPr/>
-        </p:nvSpPr>
-        <p:spPr>
-          <a:xfrm>
-            <a:off x="8325916" y="2514600"/>
-            <a:ext cx="636422" cy="256032"/>
-          </a:xfrm>
-          <a:prstGeom prst="roundRect">
-            <a:avLst>
-              <a:gd name="adj" fmla="val 50000"/>
-            </a:avLst>
-          </a:prstGeom>
-          <a:solidFill>
-            <a:srgbClr val="FDF0DD"/>
-          </a:solidFill>
-          <a:ln>
-            <a:noFill/>
-          </a:ln>
-          <a:effectLst/>
-        </p:spPr>
-        <p:style>
-          <a:lnRef idx="1">
-            <a:schemeClr val="accent1"/>
-          </a:lnRef>
-          <a:fillRef idx="3">
-            <a:schemeClr val="accent1"/>
-          </a:fillRef>
-          <a:effectRef idx="2">
-            <a:schemeClr val="accent1"/>
-          </a:effectRef>
-          <a:fontRef idx="minor">
-            <a:schemeClr val="lt1"/>
-          </a:fontRef>
-        </p:style>
-        <p:txBody>
-          <a:bodyPr rtlCol="0" anchor="ctr" lIns="50800" rIns="50800" tIns="12700" bIns="12700">
-            <a:noAutofit/>
-          </a:bodyPr>
-          <a:lstStyle/>
-          <a:p>
-            <a:pPr algn="ctr"/>
-            <a:r>
-              <a:rPr sz="900" b="1">
-                <a:solidFill>
-                  <a:srgbClr val="8A5A12"/>
-                </a:solidFill>
-                <a:latin typeface="Arial"/>
-              </a:rPr>
-              <a:t>PHASE 4</a:t>
-            </a:r>
-          </a:p>
-        </p:txBody>
-      </p:sp>
-      <p:sp>
-        <p:nvSpPr>
-          <p:cNvPr id="16" name="TextBox 15"/>
-          <p:cNvSpPr txBox="1"/>
-          <p:nvPr/>
-        </p:nvSpPr>
-        <p:spPr>
-          <a:xfrm>
-            <a:off x="8325916" y="2971800"/>
-            <a:ext cx="2997098" cy="731520"/>
-          </a:xfrm>
-          <a:prstGeom prst="rect">
-            <a:avLst/>
-          </a:prstGeom>
-          <a:noFill/>
-        </p:spPr>
-        <p:txBody>
-          <a:bodyPr wrap="square" anchor="t">
-            <a:noAutofit/>
-          </a:bodyPr>
-          <a:lstStyle/>
-          <a:p>
-            <a:pPr algn="l">
-              <a:lnSpc>
-                <a:spcPct val="115000"/>
-              </a:lnSpc>
-            </a:pPr>
-            <a:r>
-              <a:rPr sz="1450" b="1" i="0">
-                <a:solidFill>
-                  <a:srgbClr val="1E2761"/>
-                </a:solidFill>
-                <a:latin typeface="Arial"/>
-              </a:rPr>
-              <a:t>Reader / published-roster browser</a:t>
-            </a:r>
-          </a:p>
-        </p:txBody>
-      </p:sp>
-      <p:sp>
-        <p:nvSpPr>
-          <p:cNvPr id="17" name="TextBox 16"/>
-          <p:cNvSpPr txBox="1"/>
-          <p:nvPr/>
-        </p:nvSpPr>
-        <p:spPr>
-          <a:xfrm>
-            <a:off x="8325916" y="3703320"/>
-            <a:ext cx="2997098" cy="822960"/>
-          </a:xfrm>
-          <a:prstGeom prst="rect">
-            <a:avLst/>
-          </a:prstGeom>
-          <a:noFill/>
-        </p:spPr>
-        <p:txBody>
-          <a:bodyPr wrap="square" anchor="t">
-            <a:noAutofit/>
-          </a:bodyPr>
-          <a:lstStyle/>
-          <a:p>
-            <a:pPr algn="l">
-              <a:lnSpc>
-                <a:spcPct val="130000"/>
-              </a:lnSpc>
-            </a:pPr>
-            <a:r>
-              <a:rPr sz="1100" b="0" i="0">
-                <a:solidFill>
-                  <a:srgbClr val="6B6B6B"/>
-                </a:solidFill>
-                <a:latin typeface="Arial"/>
-              </a:rPr>
-              <a:t>Read-only roster browsing with PDF/CSV export for shared displays and print.</a:t>
             </a:r>
           </a:p>
         </p:txBody>
@@ -7990,7 +9107,7 @@
 </p:sld>
 </file>
 
-<file path=ppt/slides/slide17.xml><?xml version="1.0" encoding="utf-8"?>
+<file path=ppt/slides/slide19.xml><?xml version="1.0" encoding="utf-8"?>
 <p:sld xmlns:a="http://schemas.openxmlformats.org/drawingml/2006/main" xmlns:p="http://schemas.openxmlformats.org/presentationml/2006/main" xmlns:r="http://schemas.openxmlformats.org/officeDocument/2006/relationships">
   <p:cSld>
     <p:spTree>
@@ -8347,7 +9464,7 @@
                 </a:solidFill>
                 <a:latin typeface="Arial"/>
               </a:rPr>
-              <a:t>Rebuilt from a single admin screen into three working, role-scoped portals — Admin, Approver and Staff — plus a fourth (Reader, a read-only published-roster browser) reserved for a later phase.</a:t>
+              <a:t>All four role-scoped portals are now live — Admin, Approver, Staff and Reader — each behind its own sign-in. Every user lands directly in the screen built for their job.</a:t>
             </a:r>
           </a:p>
           <a:p>
@@ -8375,7 +9492,7 @@
                 </a:solidFill>
                 <a:latin typeface="Arial"/>
               </a:rPr>
-              <a:t>Every roster moves through the same tracked lifecycle: draft → submitted → approved → published (with reject and amend paths), scored out of 100 by one scoring module shared by the generator and manual edits alike.</a:t>
+              <a:t>Every roster follows the same lifecycle: draft → submitted → approved → published, with reject and amend paths and a full audit trail. One scoring engine judges both automatic generation and manual edits.</a:t>
             </a:r>
           </a:p>
           <a:p>
@@ -8403,7 +9520,7 @@
                 </a:solidFill>
                 <a:latin typeface="Arial"/>
               </a:rPr>
-              <a:t>Staff, VIC clients, shifts, rules and scoring weights are stored per boutique in one data model. The current dataset has two boutiques configured (Sydney and Melbourne); adding another is configuration, not a new build.</a:t>
+              <a:t>Staff, VIC clients, shifts and rules are all configured per boutique in one data model. The current dataset covers two boutiques (Sydney and Melbourne); adding a third is configuration, not new engineering.</a:t>
             </a:r>
           </a:p>
         </p:txBody>
@@ -8565,7 +9682,7 @@
                 </a:solidFill>
                 <a:latin typeface="Arial"/>
               </a:rPr>
-              <a:t>Store or regional operations admins, the manager who signs off each roster, and every floor employee checking their own shifts.</a:t>
+              <a:t>Operations admins, the manager who approves each roster, floor staff checking their shifts, and read-only viewers browsing published rosters.</a:t>
             </a:r>
           </a:p>
         </p:txBody>
@@ -8727,7 +9844,7 @@
                 </a:solidFill>
                 <a:latin typeface="Arial"/>
               </a:rPr>
-              <a:t>Split into four dedicated portals with real sign-in; added submit → approve → publish, live-rescoring manual edits, leave tracking, and per-boutique rules.</a:t>
+              <a:t>Skill requirements can now be scoped to a specific area of the floor (Counter, Fitting Room, Concierge…), not just the shift as a whole — carried through generation, manual edits, exports and each employee's own schedule.</a:t>
             </a:r>
           </a:p>
         </p:txBody>
@@ -8889,7 +10006,7 @@
                 </a:solidFill>
                 <a:latin typeface="Arial"/>
               </a:rPr>
-              <a:t>One codebase and one data model serve every boutique — scaling to another store is configuration inside the existing schema, not a new build.</a:t>
+              <a:t>One codebase, one data model, every boutique — a new store is configuration, not a rebuild.</a:t>
             </a:r>
           </a:p>
         </p:txBody>
@@ -9854,7 +10971,7 @@
                 </a:solidFill>
                 <a:latin typeface="Arial"/>
               </a:rPr>
-              <a:t>Published view (planned)</a:t>
+              <a:t>Published Rosters</a:t>
             </a:r>
           </a:p>
         </p:txBody>
@@ -9893,7 +11010,7 @@
                 </a:solidFill>
                 <a:latin typeface="Arial"/>
               </a:rPr>
-              <a:t>A read-only, PDF/CSV-exportable roster browser for a shared back-of-house screen or printout.</a:t>
+              <a:t>A read-only roster browser with one-click CSV and PDF export, for a shared back-of-house screen or printout.</a:t>
             </a:r>
           </a:p>
         </p:txBody>
@@ -12064,6 +13181,34 @@
                 <a:latin typeface="Arial"/>
               </a:rPr>
               <a:t>Add-from-bench and remove-in-place, no page reload</a:t>
+            </a:r>
+          </a:p>
+          <a:p>
+            <a:pPr>
+              <a:lnSpc>
+                <a:spcPct val="118000"/>
+              </a:lnSpc>
+              <a:spcAft>
+                <a:spcPts val="900"/>
+              </a:spcAft>
+            </a:pPr>
+            <a:r>
+              <a:rPr sz="1150">
+                <a:solidFill>
+                  <a:srgbClr val="C9A84C"/>
+                </a:solidFill>
+                <a:latin typeface="Arial"/>
+              </a:rPr>
+              <a:t>✦  </a:t>
+            </a:r>
+            <a:r>
+              <a:rPr sz="1150">
+                <a:solidFill>
+                  <a:srgbClr val="1A1A1A"/>
+                </a:solidFill>
+                <a:latin typeface="Arial"/>
+              </a:rPr>
+              <a:t>Reassign which area of the floor a staff member is covering, right from the same edit view</a:t>
             </a:r>
           </a:p>
           <a:p>

</xml_diff>